<commit_message>
Remove standalone minute-budget chips from slides
title_bar now drops any tag ending in 'min' (2 min, 3 min, 45 min, …)
so the amber time chip no longer appears on slides. Semantic tags
(gap, service, code, summary) are unaffected. Deck regenerated.
</commit_message>
<xml_diff>
--- a/docs/PetStore_Demo_45min.pptx
+++ b/docs/PetStore_Demo_45min.pptx
@@ -5923,86 +5923,7 @@
       </p:sp>
       <p:sp>
         <p:nvSpPr>
-          <p:cNvPr id="3" name="Rectangle 2"/>
-          <p:cNvSpPr/>
-          <p:nvPr/>
-        </p:nvSpPr>
-        <p:spPr>
-          <a:xfrm>
-            <a:off x="10378440" y="274320"/>
-            <a:ext cx="1600200" cy="502920"/>
-          </a:xfrm>
-          <a:prstGeom prst="rect">
-            <a:avLst/>
-          </a:prstGeom>
-          <a:solidFill>
-            <a:srgbClr val="C97C2F"/>
-          </a:solidFill>
-          <a:ln>
-            <a:noFill/>
-          </a:ln>
-          <a:effectLst/>
-        </p:spPr>
-        <p:style>
-          <a:lnRef idx="1">
-            <a:schemeClr val="accent1"/>
-          </a:lnRef>
-          <a:fillRef idx="3">
-            <a:schemeClr val="accent1"/>
-          </a:fillRef>
-          <a:effectRef idx="2">
-            <a:schemeClr val="accent1"/>
-          </a:effectRef>
-          <a:fontRef idx="minor">
-            <a:schemeClr val="lt1"/>
-          </a:fontRef>
-        </p:style>
-        <p:txBody>
-          <a:bodyPr rtlCol="0" anchor="ctr"/>
-          <a:lstStyle/>
-          <a:p>
-            <a:pPr algn="ctr"/>
-          </a:p>
-        </p:txBody>
-      </p:sp>
-      <p:sp>
-        <p:nvSpPr>
-          <p:cNvPr id="4" name="TextBox 3"/>
-          <p:cNvSpPr txBox="1"/>
-          <p:nvPr/>
-        </p:nvSpPr>
-        <p:spPr>
-          <a:xfrm>
-            <a:off x="10378440" y="274320"/>
-            <a:ext cx="1600200" cy="502920"/>
-          </a:xfrm>
-          <a:prstGeom prst="rect">
-            <a:avLst/>
-          </a:prstGeom>
-          <a:noFill/>
-        </p:spPr>
-        <p:txBody>
-          <a:bodyPr wrap="square" anchor="ctr">
-            <a:spAutoFit/>
-          </a:bodyPr>
-          <a:lstStyle/>
-          <a:p>
-            <a:pPr algn="ctr"/>
-            <a:r>
-              <a:rPr sz="1300" b="1">
-                <a:solidFill>
-                  <a:srgbClr val="FFFFFF"/>
-                </a:solidFill>
-                <a:latin typeface="Calibri"/>
-              </a:rPr>
-              <a:t>3 min</a:t>
-            </a:r>
-          </a:p>
-        </p:txBody>
-      </p:sp>
-      <p:sp>
-        <p:nvSpPr>
-          <p:cNvPr id="5" name="TextBox 4"/>
+          <p:cNvPr id="3" name="TextBox 2"/>
           <p:cNvSpPr txBox="1"/>
           <p:nvPr/>
         </p:nvSpPr>
@@ -6037,7 +5958,7 @@
       </p:sp>
       <p:sp>
         <p:nvSpPr>
-          <p:cNvPr id="6" name="TextBox 5"/>
+          <p:cNvPr id="4" name="TextBox 3"/>
           <p:cNvSpPr txBox="1"/>
           <p:nvPr/>
         </p:nvSpPr>
@@ -6072,7 +5993,7 @@
       </p:sp>
       <p:sp>
         <p:nvSpPr>
-          <p:cNvPr id="7" name="TextBox 6"/>
+          <p:cNvPr id="5" name="TextBox 4"/>
           <p:cNvSpPr txBox="1"/>
           <p:nvPr/>
         </p:nvSpPr>
@@ -6223,7 +6144,7 @@
       </p:sp>
       <p:sp>
         <p:nvSpPr>
-          <p:cNvPr id="8" name="Rectangle 7"/>
+          <p:cNvPr id="6" name="Rectangle 5"/>
           <p:cNvSpPr/>
           <p:nvPr/>
         </p:nvSpPr>
@@ -6267,7 +6188,7 @@
       </p:sp>
       <p:sp>
         <p:nvSpPr>
-          <p:cNvPr id="9" name="TextBox 8"/>
+          <p:cNvPr id="7" name="TextBox 6"/>
           <p:cNvSpPr txBox="1"/>
           <p:nvPr/>
         </p:nvSpPr>
@@ -6302,7 +6223,7 @@
       </p:sp>
       <p:sp>
         <p:nvSpPr>
-          <p:cNvPr id="10" name="TextBox 9"/>
+          <p:cNvPr id="8" name="TextBox 7"/>
           <p:cNvSpPr txBox="1"/>
           <p:nvPr/>
         </p:nvSpPr>
@@ -6467,86 +6388,7 @@
       </p:sp>
       <p:sp>
         <p:nvSpPr>
-          <p:cNvPr id="3" name="Rectangle 2"/>
-          <p:cNvSpPr/>
-          <p:nvPr/>
-        </p:nvSpPr>
-        <p:spPr>
-          <a:xfrm>
-            <a:off x="10378440" y="274320"/>
-            <a:ext cx="1600200" cy="502920"/>
-          </a:xfrm>
-          <a:prstGeom prst="rect">
-            <a:avLst/>
-          </a:prstGeom>
-          <a:solidFill>
-            <a:srgbClr val="C97C2F"/>
-          </a:solidFill>
-          <a:ln>
-            <a:noFill/>
-          </a:ln>
-          <a:effectLst/>
-        </p:spPr>
-        <p:style>
-          <a:lnRef idx="1">
-            <a:schemeClr val="accent1"/>
-          </a:lnRef>
-          <a:fillRef idx="3">
-            <a:schemeClr val="accent1"/>
-          </a:fillRef>
-          <a:effectRef idx="2">
-            <a:schemeClr val="accent1"/>
-          </a:effectRef>
-          <a:fontRef idx="minor">
-            <a:schemeClr val="lt1"/>
-          </a:fontRef>
-        </p:style>
-        <p:txBody>
-          <a:bodyPr rtlCol="0" anchor="ctr"/>
-          <a:lstStyle/>
-          <a:p>
-            <a:pPr algn="ctr"/>
-          </a:p>
-        </p:txBody>
-      </p:sp>
-      <p:sp>
-        <p:nvSpPr>
-          <p:cNvPr id="4" name="TextBox 3"/>
-          <p:cNvSpPr txBox="1"/>
-          <p:nvPr/>
-        </p:nvSpPr>
-        <p:spPr>
-          <a:xfrm>
-            <a:off x="10378440" y="274320"/>
-            <a:ext cx="1600200" cy="502920"/>
-          </a:xfrm>
-          <a:prstGeom prst="rect">
-            <a:avLst/>
-          </a:prstGeom>
-          <a:noFill/>
-        </p:spPr>
-        <p:txBody>
-          <a:bodyPr wrap="square" anchor="ctr">
-            <a:spAutoFit/>
-          </a:bodyPr>
-          <a:lstStyle/>
-          <a:p>
-            <a:pPr algn="ctr"/>
-            <a:r>
-              <a:rPr sz="1300" b="1">
-                <a:solidFill>
-                  <a:srgbClr val="FFFFFF"/>
-                </a:solidFill>
-                <a:latin typeface="Calibri"/>
-              </a:rPr>
-              <a:t>5 min</a:t>
-            </a:r>
-          </a:p>
-        </p:txBody>
-      </p:sp>
-      <p:sp>
-        <p:nvSpPr>
-          <p:cNvPr id="5" name="TextBox 4"/>
+          <p:cNvPr id="3" name="TextBox 2"/>
           <p:cNvSpPr txBox="1"/>
           <p:nvPr/>
         </p:nvSpPr>
@@ -6581,7 +6423,7 @@
       </p:sp>
       <p:sp>
         <p:nvSpPr>
-          <p:cNvPr id="6" name="TextBox 5"/>
+          <p:cNvPr id="4" name="TextBox 3"/>
           <p:cNvSpPr txBox="1"/>
           <p:nvPr/>
         </p:nvSpPr>
@@ -6616,7 +6458,7 @@
       </p:sp>
       <p:graphicFrame>
         <p:nvGraphicFramePr>
-          <p:cNvPr id="7" name="Table 6"/>
+          <p:cNvPr id="5" name="Table 4"/>
           <p:cNvGraphicFramePr>
             <a:graphicFrameLocks noGrp="1"/>
           </p:cNvGraphicFramePr>
@@ -7309,7 +7151,7 @@
       </p:graphicFrame>
       <p:sp>
         <p:nvSpPr>
-          <p:cNvPr id="8" name="TextBox 7"/>
+          <p:cNvPr id="6" name="TextBox 5"/>
           <p:cNvSpPr txBox="1"/>
           <p:nvPr/>
         </p:nvSpPr>
@@ -7406,86 +7248,7 @@
       </p:sp>
       <p:sp>
         <p:nvSpPr>
-          <p:cNvPr id="3" name="Rectangle 2"/>
-          <p:cNvSpPr/>
-          <p:nvPr/>
-        </p:nvSpPr>
-        <p:spPr>
-          <a:xfrm>
-            <a:off x="10378440" y="274320"/>
-            <a:ext cx="1600200" cy="502920"/>
-          </a:xfrm>
-          <a:prstGeom prst="rect">
-            <a:avLst/>
-          </a:prstGeom>
-          <a:solidFill>
-            <a:srgbClr val="C97C2F"/>
-          </a:solidFill>
-          <a:ln>
-            <a:noFill/>
-          </a:ln>
-          <a:effectLst/>
-        </p:spPr>
-        <p:style>
-          <a:lnRef idx="1">
-            <a:schemeClr val="accent1"/>
-          </a:lnRef>
-          <a:fillRef idx="3">
-            <a:schemeClr val="accent1"/>
-          </a:fillRef>
-          <a:effectRef idx="2">
-            <a:schemeClr val="accent1"/>
-          </a:effectRef>
-          <a:fontRef idx="minor">
-            <a:schemeClr val="lt1"/>
-          </a:fontRef>
-        </p:style>
-        <p:txBody>
-          <a:bodyPr rtlCol="0" anchor="ctr"/>
-          <a:lstStyle/>
-          <a:p>
-            <a:pPr algn="ctr"/>
-          </a:p>
-        </p:txBody>
-      </p:sp>
-      <p:sp>
-        <p:nvSpPr>
-          <p:cNvPr id="4" name="TextBox 3"/>
-          <p:cNvSpPr txBox="1"/>
-          <p:nvPr/>
-        </p:nvSpPr>
-        <p:spPr>
-          <a:xfrm>
-            <a:off x="10378440" y="274320"/>
-            <a:ext cx="1600200" cy="502920"/>
-          </a:xfrm>
-          <a:prstGeom prst="rect">
-            <a:avLst/>
-          </a:prstGeom>
-          <a:noFill/>
-        </p:spPr>
-        <p:txBody>
-          <a:bodyPr wrap="square" anchor="ctr">
-            <a:spAutoFit/>
-          </a:bodyPr>
-          <a:lstStyle/>
-          <a:p>
-            <a:pPr algn="ctr"/>
-            <a:r>
-              <a:rPr sz="1300" b="1">
-                <a:solidFill>
-                  <a:srgbClr val="FFFFFF"/>
-                </a:solidFill>
-                <a:latin typeface="Calibri"/>
-              </a:rPr>
-              <a:t>4 min</a:t>
-            </a:r>
-          </a:p>
-        </p:txBody>
-      </p:sp>
-      <p:sp>
-        <p:nvSpPr>
-          <p:cNvPr id="5" name="TextBox 4"/>
+          <p:cNvPr id="3" name="TextBox 2"/>
           <p:cNvSpPr txBox="1"/>
           <p:nvPr/>
         </p:nvSpPr>
@@ -7520,7 +7283,7 @@
       </p:sp>
       <p:sp>
         <p:nvSpPr>
-          <p:cNvPr id="6" name="TextBox 5"/>
+          <p:cNvPr id="4" name="TextBox 3"/>
           <p:cNvSpPr txBox="1"/>
           <p:nvPr/>
         </p:nvSpPr>
@@ -7555,7 +7318,7 @@
       </p:sp>
       <p:sp>
         <p:nvSpPr>
-          <p:cNvPr id="7" name="TextBox 6"/>
+          <p:cNvPr id="5" name="TextBox 4"/>
           <p:cNvSpPr txBox="1"/>
           <p:nvPr/>
         </p:nvSpPr>
@@ -7590,7 +7353,7 @@
       </p:sp>
       <p:graphicFrame>
         <p:nvGraphicFramePr>
-          <p:cNvPr id="8" name="Table 7"/>
+          <p:cNvPr id="6" name="Table 5"/>
           <p:cNvGraphicFramePr>
             <a:graphicFrameLocks noGrp="1"/>
           </p:cNvGraphicFramePr>
@@ -8061,7 +7824,7 @@
       </p:graphicFrame>
       <p:sp>
         <p:nvSpPr>
-          <p:cNvPr id="9" name="Rectangle 8"/>
+          <p:cNvPr id="7" name="Rectangle 6"/>
           <p:cNvSpPr/>
           <p:nvPr/>
         </p:nvSpPr>
@@ -8105,7 +7868,7 @@
       </p:sp>
       <p:sp>
         <p:nvSpPr>
-          <p:cNvPr id="10" name="TextBox 9"/>
+          <p:cNvPr id="8" name="TextBox 7"/>
           <p:cNvSpPr txBox="1"/>
           <p:nvPr/>
         </p:nvSpPr>
@@ -8139,7 +7902,7 @@
       </p:sp>
       <p:sp>
         <p:nvSpPr>
-          <p:cNvPr id="11" name="TextBox 10"/>
+          <p:cNvPr id="9" name="TextBox 8"/>
           <p:cNvSpPr txBox="1"/>
           <p:nvPr/>
         </p:nvSpPr>
@@ -8288,86 +8051,7 @@
       </p:sp>
       <p:sp>
         <p:nvSpPr>
-          <p:cNvPr id="3" name="Rectangle 2"/>
-          <p:cNvSpPr/>
-          <p:nvPr/>
-        </p:nvSpPr>
-        <p:spPr>
-          <a:xfrm>
-            <a:off x="10378440" y="274320"/>
-            <a:ext cx="1600200" cy="502920"/>
-          </a:xfrm>
-          <a:prstGeom prst="rect">
-            <a:avLst/>
-          </a:prstGeom>
-          <a:solidFill>
-            <a:srgbClr val="C97C2F"/>
-          </a:solidFill>
-          <a:ln>
-            <a:noFill/>
-          </a:ln>
-          <a:effectLst/>
-        </p:spPr>
-        <p:style>
-          <a:lnRef idx="1">
-            <a:schemeClr val="accent1"/>
-          </a:lnRef>
-          <a:fillRef idx="3">
-            <a:schemeClr val="accent1"/>
-          </a:fillRef>
-          <a:effectRef idx="2">
-            <a:schemeClr val="accent1"/>
-          </a:effectRef>
-          <a:fontRef idx="minor">
-            <a:schemeClr val="lt1"/>
-          </a:fontRef>
-        </p:style>
-        <p:txBody>
-          <a:bodyPr rtlCol="0" anchor="ctr"/>
-          <a:lstStyle/>
-          <a:p>
-            <a:pPr algn="ctr"/>
-          </a:p>
-        </p:txBody>
-      </p:sp>
-      <p:sp>
-        <p:nvSpPr>
-          <p:cNvPr id="4" name="TextBox 3"/>
-          <p:cNvSpPr txBox="1"/>
-          <p:nvPr/>
-        </p:nvSpPr>
-        <p:spPr>
-          <a:xfrm>
-            <a:off x="10378440" y="274320"/>
-            <a:ext cx="1600200" cy="502920"/>
-          </a:xfrm>
-          <a:prstGeom prst="rect">
-            <a:avLst/>
-          </a:prstGeom>
-          <a:noFill/>
-        </p:spPr>
-        <p:txBody>
-          <a:bodyPr wrap="square" anchor="ctr">
-            <a:spAutoFit/>
-          </a:bodyPr>
-          <a:lstStyle/>
-          <a:p>
-            <a:pPr algn="ctr"/>
-            <a:r>
-              <a:rPr sz="1300" b="1">
-                <a:solidFill>
-                  <a:srgbClr val="FFFFFF"/>
-                </a:solidFill>
-                <a:latin typeface="Calibri"/>
-              </a:rPr>
-              <a:t>4 min</a:t>
-            </a:r>
-          </a:p>
-        </p:txBody>
-      </p:sp>
-      <p:sp>
-        <p:nvSpPr>
-          <p:cNvPr id="5" name="TextBox 4"/>
+          <p:cNvPr id="3" name="TextBox 2"/>
           <p:cNvSpPr txBox="1"/>
           <p:nvPr/>
         </p:nvSpPr>
@@ -8402,7 +8086,7 @@
       </p:sp>
       <p:sp>
         <p:nvSpPr>
-          <p:cNvPr id="6" name="TextBox 5"/>
+          <p:cNvPr id="4" name="TextBox 3"/>
           <p:cNvSpPr txBox="1"/>
           <p:nvPr/>
         </p:nvSpPr>
@@ -8437,7 +8121,7 @@
       </p:sp>
       <p:graphicFrame>
         <p:nvGraphicFramePr>
-          <p:cNvPr id="7" name="Table 6"/>
+          <p:cNvPr id="5" name="Table 4"/>
           <p:cNvGraphicFramePr>
             <a:graphicFrameLocks noGrp="1"/>
           </p:cNvGraphicFramePr>
@@ -9056,7 +8740,7 @@
       </p:graphicFrame>
       <p:sp>
         <p:nvSpPr>
-          <p:cNvPr id="8" name="Rectangle 7"/>
+          <p:cNvPr id="6" name="Rectangle 5"/>
           <p:cNvSpPr/>
           <p:nvPr/>
         </p:nvSpPr>
@@ -9100,7 +8784,7 @@
       </p:sp>
       <p:sp>
         <p:nvSpPr>
-          <p:cNvPr id="9" name="TextBox 8"/>
+          <p:cNvPr id="7" name="TextBox 6"/>
           <p:cNvSpPr txBox="1"/>
           <p:nvPr/>
         </p:nvSpPr>
@@ -9213,86 +8897,7 @@
       </p:sp>
       <p:sp>
         <p:nvSpPr>
-          <p:cNvPr id="3" name="Rectangle 2"/>
-          <p:cNvSpPr/>
-          <p:nvPr/>
-        </p:nvSpPr>
-        <p:spPr>
-          <a:xfrm>
-            <a:off x="10378440" y="274320"/>
-            <a:ext cx="1600200" cy="502920"/>
-          </a:xfrm>
-          <a:prstGeom prst="rect">
-            <a:avLst/>
-          </a:prstGeom>
-          <a:solidFill>
-            <a:srgbClr val="C97C2F"/>
-          </a:solidFill>
-          <a:ln>
-            <a:noFill/>
-          </a:ln>
-          <a:effectLst/>
-        </p:spPr>
-        <p:style>
-          <a:lnRef idx="1">
-            <a:schemeClr val="accent1"/>
-          </a:lnRef>
-          <a:fillRef idx="3">
-            <a:schemeClr val="accent1"/>
-          </a:fillRef>
-          <a:effectRef idx="2">
-            <a:schemeClr val="accent1"/>
-          </a:effectRef>
-          <a:fontRef idx="minor">
-            <a:schemeClr val="lt1"/>
-          </a:fontRef>
-        </p:style>
-        <p:txBody>
-          <a:bodyPr rtlCol="0" anchor="ctr"/>
-          <a:lstStyle/>
-          <a:p>
-            <a:pPr algn="ctr"/>
-          </a:p>
-        </p:txBody>
-      </p:sp>
-      <p:sp>
-        <p:nvSpPr>
-          <p:cNvPr id="4" name="TextBox 3"/>
-          <p:cNvSpPr txBox="1"/>
-          <p:nvPr/>
-        </p:nvSpPr>
-        <p:spPr>
-          <a:xfrm>
-            <a:off x="10378440" y="274320"/>
-            <a:ext cx="1600200" cy="502920"/>
-          </a:xfrm>
-          <a:prstGeom prst="rect">
-            <a:avLst/>
-          </a:prstGeom>
-          <a:noFill/>
-        </p:spPr>
-        <p:txBody>
-          <a:bodyPr wrap="square" anchor="ctr">
-            <a:spAutoFit/>
-          </a:bodyPr>
-          <a:lstStyle/>
-          <a:p>
-            <a:pPr algn="ctr"/>
-            <a:r>
-              <a:rPr sz="1300" b="1">
-                <a:solidFill>
-                  <a:srgbClr val="FFFFFF"/>
-                </a:solidFill>
-                <a:latin typeface="Calibri"/>
-              </a:rPr>
-              <a:t>3 min</a:t>
-            </a:r>
-          </a:p>
-        </p:txBody>
-      </p:sp>
-      <p:sp>
-        <p:nvSpPr>
-          <p:cNvPr id="5" name="TextBox 4"/>
+          <p:cNvPr id="3" name="TextBox 2"/>
           <p:cNvSpPr txBox="1"/>
           <p:nvPr/>
         </p:nvSpPr>
@@ -9327,7 +8932,7 @@
       </p:sp>
       <p:sp>
         <p:nvSpPr>
-          <p:cNvPr id="6" name="TextBox 5"/>
+          <p:cNvPr id="4" name="TextBox 3"/>
           <p:cNvSpPr txBox="1"/>
           <p:nvPr/>
         </p:nvSpPr>
@@ -9362,7 +8967,7 @@
       </p:sp>
       <p:pic>
         <p:nvPicPr>
-          <p:cNvPr id="7" name="Picture 6" descr="petstore_architecture.png"/>
+          <p:cNvPr id="5" name="Picture 4" descr="petstore_architecture.png"/>
           <p:cNvPicPr>
             <a:picLocks noChangeAspect="1"/>
           </p:cNvPicPr>
@@ -10881,86 +10486,7 @@
       </p:sp>
       <p:sp>
         <p:nvSpPr>
-          <p:cNvPr id="3" name="Rectangle 2"/>
-          <p:cNvSpPr/>
-          <p:nvPr/>
-        </p:nvSpPr>
-        <p:spPr>
-          <a:xfrm>
-            <a:off x="10378440" y="274320"/>
-            <a:ext cx="1600200" cy="502920"/>
-          </a:xfrm>
-          <a:prstGeom prst="rect">
-            <a:avLst/>
-          </a:prstGeom>
-          <a:solidFill>
-            <a:srgbClr val="C97C2F"/>
-          </a:solidFill>
-          <a:ln>
-            <a:noFill/>
-          </a:ln>
-          <a:effectLst/>
-        </p:spPr>
-        <p:style>
-          <a:lnRef idx="1">
-            <a:schemeClr val="accent1"/>
-          </a:lnRef>
-          <a:fillRef idx="3">
-            <a:schemeClr val="accent1"/>
-          </a:fillRef>
-          <a:effectRef idx="2">
-            <a:schemeClr val="accent1"/>
-          </a:effectRef>
-          <a:fontRef idx="minor">
-            <a:schemeClr val="lt1"/>
-          </a:fontRef>
-        </p:style>
-        <p:txBody>
-          <a:bodyPr rtlCol="0" anchor="ctr"/>
-          <a:lstStyle/>
-          <a:p>
-            <a:pPr algn="ctr"/>
-          </a:p>
-        </p:txBody>
-      </p:sp>
-      <p:sp>
-        <p:nvSpPr>
-          <p:cNvPr id="4" name="TextBox 3"/>
-          <p:cNvSpPr txBox="1"/>
-          <p:nvPr/>
-        </p:nvSpPr>
-        <p:spPr>
-          <a:xfrm>
-            <a:off x="10378440" y="274320"/>
-            <a:ext cx="1600200" cy="502920"/>
-          </a:xfrm>
-          <a:prstGeom prst="rect">
-            <a:avLst/>
-          </a:prstGeom>
-          <a:noFill/>
-        </p:spPr>
-        <p:txBody>
-          <a:bodyPr wrap="square" anchor="ctr">
-            <a:spAutoFit/>
-          </a:bodyPr>
-          <a:lstStyle/>
-          <a:p>
-            <a:pPr algn="ctr"/>
-            <a:r>
-              <a:rPr sz="1300" b="1">
-                <a:solidFill>
-                  <a:srgbClr val="FFFFFF"/>
-                </a:solidFill>
-                <a:latin typeface="Calibri"/>
-              </a:rPr>
-              <a:t>45 min</a:t>
-            </a:r>
-          </a:p>
-        </p:txBody>
-      </p:sp>
-      <p:sp>
-        <p:nvSpPr>
-          <p:cNvPr id="5" name="TextBox 4"/>
+          <p:cNvPr id="3" name="TextBox 2"/>
           <p:cNvSpPr txBox="1"/>
           <p:nvPr/>
         </p:nvSpPr>
@@ -10995,7 +10521,7 @@
       </p:sp>
       <p:sp>
         <p:nvSpPr>
-          <p:cNvPr id="6" name="TextBox 5"/>
+          <p:cNvPr id="4" name="TextBox 3"/>
           <p:cNvSpPr txBox="1"/>
           <p:nvPr/>
         </p:nvSpPr>
@@ -11030,7 +10556,7 @@
       </p:sp>
       <p:graphicFrame>
         <p:nvGraphicFramePr>
-          <p:cNvPr id="7" name="Table 6"/>
+          <p:cNvPr id="5" name="Table 4"/>
           <p:cNvGraphicFramePr>
             <a:graphicFrameLocks noGrp="1"/>
           </p:cNvGraphicFramePr>
@@ -18528,86 +18054,7 @@
       </p:sp>
       <p:sp>
         <p:nvSpPr>
-          <p:cNvPr id="3" name="Rectangle 2"/>
-          <p:cNvSpPr/>
-          <p:nvPr/>
-        </p:nvSpPr>
-        <p:spPr>
-          <a:xfrm>
-            <a:off x="10378440" y="274320"/>
-            <a:ext cx="1600200" cy="502920"/>
-          </a:xfrm>
-          <a:prstGeom prst="rect">
-            <a:avLst/>
-          </a:prstGeom>
-          <a:solidFill>
-            <a:srgbClr val="C97C2F"/>
-          </a:solidFill>
-          <a:ln>
-            <a:noFill/>
-          </a:ln>
-          <a:effectLst/>
-        </p:spPr>
-        <p:style>
-          <a:lnRef idx="1">
-            <a:schemeClr val="accent1"/>
-          </a:lnRef>
-          <a:fillRef idx="3">
-            <a:schemeClr val="accent1"/>
-          </a:fillRef>
-          <a:effectRef idx="2">
-            <a:schemeClr val="accent1"/>
-          </a:effectRef>
-          <a:fontRef idx="minor">
-            <a:schemeClr val="lt1"/>
-          </a:fontRef>
-        </p:style>
-        <p:txBody>
-          <a:bodyPr rtlCol="0" anchor="ctr"/>
-          <a:lstStyle/>
-          <a:p>
-            <a:pPr algn="ctr"/>
-          </a:p>
-        </p:txBody>
-      </p:sp>
-      <p:sp>
-        <p:nvSpPr>
-          <p:cNvPr id="4" name="TextBox 3"/>
-          <p:cNvSpPr txBox="1"/>
-          <p:nvPr/>
-        </p:nvSpPr>
-        <p:spPr>
-          <a:xfrm>
-            <a:off x="10378440" y="274320"/>
-            <a:ext cx="1600200" cy="502920"/>
-          </a:xfrm>
-          <a:prstGeom prst="rect">
-            <a:avLst/>
-          </a:prstGeom>
-          <a:noFill/>
-        </p:spPr>
-        <p:txBody>
-          <a:bodyPr wrap="square" anchor="ctr">
-            <a:spAutoFit/>
-          </a:bodyPr>
-          <a:lstStyle/>
-          <a:p>
-            <a:pPr algn="ctr"/>
-            <a:r>
-              <a:rPr sz="1300" b="1">
-                <a:solidFill>
-                  <a:srgbClr val="FFFFFF"/>
-                </a:solidFill>
-                <a:latin typeface="Calibri"/>
-              </a:rPr>
-              <a:t>2 min</a:t>
-            </a:r>
-          </a:p>
-        </p:txBody>
-      </p:sp>
-      <p:sp>
-        <p:nvSpPr>
-          <p:cNvPr id="5" name="TextBox 4"/>
+          <p:cNvPr id="3" name="TextBox 2"/>
           <p:cNvSpPr txBox="1"/>
           <p:nvPr/>
         </p:nvSpPr>
@@ -18642,7 +18089,7 @@
       </p:sp>
       <p:sp>
         <p:nvSpPr>
-          <p:cNvPr id="6" name="TextBox 5"/>
+          <p:cNvPr id="4" name="TextBox 3"/>
           <p:cNvSpPr txBox="1"/>
           <p:nvPr/>
         </p:nvSpPr>
@@ -18677,7 +18124,7 @@
       </p:sp>
       <p:sp>
         <p:nvSpPr>
-          <p:cNvPr id="7" name="TextBox 6"/>
+          <p:cNvPr id="5" name="TextBox 4"/>
           <p:cNvSpPr txBox="1"/>
           <p:nvPr/>
         </p:nvSpPr>
@@ -20985,86 +20432,7 @@
       </p:sp>
       <p:sp>
         <p:nvSpPr>
-          <p:cNvPr id="3" name="Rectangle 2"/>
-          <p:cNvSpPr/>
-          <p:nvPr/>
-        </p:nvSpPr>
-        <p:spPr>
-          <a:xfrm>
-            <a:off x="10378440" y="274320"/>
-            <a:ext cx="1600200" cy="502920"/>
-          </a:xfrm>
-          <a:prstGeom prst="rect">
-            <a:avLst/>
-          </a:prstGeom>
-          <a:solidFill>
-            <a:srgbClr val="C97C2F"/>
-          </a:solidFill>
-          <a:ln>
-            <a:noFill/>
-          </a:ln>
-          <a:effectLst/>
-        </p:spPr>
-        <p:style>
-          <a:lnRef idx="1">
-            <a:schemeClr val="accent1"/>
-          </a:lnRef>
-          <a:fillRef idx="3">
-            <a:schemeClr val="accent1"/>
-          </a:fillRef>
-          <a:effectRef idx="2">
-            <a:schemeClr val="accent1"/>
-          </a:effectRef>
-          <a:fontRef idx="minor">
-            <a:schemeClr val="lt1"/>
-          </a:fontRef>
-        </p:style>
-        <p:txBody>
-          <a:bodyPr rtlCol="0" anchor="ctr"/>
-          <a:lstStyle/>
-          <a:p>
-            <a:pPr algn="ctr"/>
-          </a:p>
-        </p:txBody>
-      </p:sp>
-      <p:sp>
-        <p:nvSpPr>
-          <p:cNvPr id="4" name="TextBox 3"/>
-          <p:cNvSpPr txBox="1"/>
-          <p:nvPr/>
-        </p:nvSpPr>
-        <p:spPr>
-          <a:xfrm>
-            <a:off x="10378440" y="274320"/>
-            <a:ext cx="1600200" cy="502920"/>
-          </a:xfrm>
-          <a:prstGeom prst="rect">
-            <a:avLst/>
-          </a:prstGeom>
-          <a:noFill/>
-        </p:spPr>
-        <p:txBody>
-          <a:bodyPr wrap="square" anchor="ctr">
-            <a:spAutoFit/>
-          </a:bodyPr>
-          <a:lstStyle/>
-          <a:p>
-            <a:pPr algn="ctr"/>
-            <a:r>
-              <a:rPr sz="1300" b="1">
-                <a:solidFill>
-                  <a:srgbClr val="FFFFFF"/>
-                </a:solidFill>
-                <a:latin typeface="Calibri"/>
-              </a:rPr>
-              <a:t>2 min</a:t>
-            </a:r>
-          </a:p>
-        </p:txBody>
-      </p:sp>
-      <p:sp>
-        <p:nvSpPr>
-          <p:cNvPr id="5" name="TextBox 4"/>
+          <p:cNvPr id="3" name="TextBox 2"/>
           <p:cNvSpPr txBox="1"/>
           <p:nvPr/>
         </p:nvSpPr>
@@ -21099,7 +20467,7 @@
       </p:sp>
       <p:sp>
         <p:nvSpPr>
-          <p:cNvPr id="6" name="TextBox 5"/>
+          <p:cNvPr id="4" name="TextBox 3"/>
           <p:cNvSpPr txBox="1"/>
           <p:nvPr/>
         </p:nvSpPr>
@@ -21134,7 +20502,7 @@
       </p:sp>
       <p:sp>
         <p:nvSpPr>
-          <p:cNvPr id="7" name="TextBox 6"/>
+          <p:cNvPr id="5" name="TextBox 4"/>
           <p:cNvSpPr txBox="1"/>
           <p:nvPr/>
         </p:nvSpPr>
@@ -21269,7 +20637,7 @@
       </p:sp>
       <p:sp>
         <p:nvSpPr>
-          <p:cNvPr id="8" name="Rectangle 7"/>
+          <p:cNvPr id="6" name="Rectangle 5"/>
           <p:cNvSpPr/>
           <p:nvPr/>
         </p:nvSpPr>
@@ -21313,7 +20681,7 @@
       </p:sp>
       <p:sp>
         <p:nvSpPr>
-          <p:cNvPr id="9" name="TextBox 8"/>
+          <p:cNvPr id="7" name="TextBox 6"/>
           <p:cNvSpPr txBox="1"/>
           <p:nvPr/>
         </p:nvSpPr>
@@ -21348,7 +20716,7 @@
       </p:sp>
       <p:sp>
         <p:nvSpPr>
-          <p:cNvPr id="10" name="TextBox 9"/>
+          <p:cNvPr id="8" name="TextBox 7"/>
           <p:cNvSpPr txBox="1"/>
           <p:nvPr/>
         </p:nvSpPr>
@@ -21497,86 +20865,7 @@
       </p:sp>
       <p:sp>
         <p:nvSpPr>
-          <p:cNvPr id="3" name="Rectangle 2"/>
-          <p:cNvSpPr/>
-          <p:nvPr/>
-        </p:nvSpPr>
-        <p:spPr>
-          <a:xfrm>
-            <a:off x="10378440" y="274320"/>
-            <a:ext cx="1600200" cy="502920"/>
-          </a:xfrm>
-          <a:prstGeom prst="rect">
-            <a:avLst/>
-          </a:prstGeom>
-          <a:solidFill>
-            <a:srgbClr val="C97C2F"/>
-          </a:solidFill>
-          <a:ln>
-            <a:noFill/>
-          </a:ln>
-          <a:effectLst/>
-        </p:spPr>
-        <p:style>
-          <a:lnRef idx="1">
-            <a:schemeClr val="accent1"/>
-          </a:lnRef>
-          <a:fillRef idx="3">
-            <a:schemeClr val="accent1"/>
-          </a:fillRef>
-          <a:effectRef idx="2">
-            <a:schemeClr val="accent1"/>
-          </a:effectRef>
-          <a:fontRef idx="minor">
-            <a:schemeClr val="lt1"/>
-          </a:fontRef>
-        </p:style>
-        <p:txBody>
-          <a:bodyPr rtlCol="0" anchor="ctr"/>
-          <a:lstStyle/>
-          <a:p>
-            <a:pPr algn="ctr"/>
-          </a:p>
-        </p:txBody>
-      </p:sp>
-      <p:sp>
-        <p:nvSpPr>
-          <p:cNvPr id="4" name="TextBox 3"/>
-          <p:cNvSpPr txBox="1"/>
-          <p:nvPr/>
-        </p:nvSpPr>
-        <p:spPr>
-          <a:xfrm>
-            <a:off x="10378440" y="274320"/>
-            <a:ext cx="1600200" cy="502920"/>
-          </a:xfrm>
-          <a:prstGeom prst="rect">
-            <a:avLst/>
-          </a:prstGeom>
-          <a:noFill/>
-        </p:spPr>
-        <p:txBody>
-          <a:bodyPr wrap="square" anchor="ctr">
-            <a:spAutoFit/>
-          </a:bodyPr>
-          <a:lstStyle/>
-          <a:p>
-            <a:pPr algn="ctr"/>
-            <a:r>
-              <a:rPr sz="1300" b="1">
-                <a:solidFill>
-                  <a:srgbClr val="FFFFFF"/>
-                </a:solidFill>
-                <a:latin typeface="Calibri"/>
-              </a:rPr>
-              <a:t>5 min</a:t>
-            </a:r>
-          </a:p>
-        </p:txBody>
-      </p:sp>
-      <p:sp>
-        <p:nvSpPr>
-          <p:cNvPr id="5" name="TextBox 4"/>
+          <p:cNvPr id="3" name="TextBox 2"/>
           <p:cNvSpPr txBox="1"/>
           <p:nvPr/>
         </p:nvSpPr>
@@ -21611,7 +20900,7 @@
       </p:sp>
       <p:sp>
         <p:nvSpPr>
-          <p:cNvPr id="6" name="TextBox 5"/>
+          <p:cNvPr id="4" name="TextBox 3"/>
           <p:cNvSpPr txBox="1"/>
           <p:nvPr/>
         </p:nvSpPr>
@@ -21646,7 +20935,7 @@
       </p:sp>
       <p:sp>
         <p:nvSpPr>
-          <p:cNvPr id="7" name="TextBox 6"/>
+          <p:cNvPr id="5" name="TextBox 4"/>
           <p:cNvSpPr txBox="1"/>
           <p:nvPr/>
         </p:nvSpPr>
@@ -21859,86 +21148,7 @@
       </p:sp>
       <p:sp>
         <p:nvSpPr>
-          <p:cNvPr id="3" name="Rectangle 2"/>
-          <p:cNvSpPr/>
-          <p:nvPr/>
-        </p:nvSpPr>
-        <p:spPr>
-          <a:xfrm>
-            <a:off x="10378440" y="274320"/>
-            <a:ext cx="1600200" cy="502920"/>
-          </a:xfrm>
-          <a:prstGeom prst="rect">
-            <a:avLst/>
-          </a:prstGeom>
-          <a:solidFill>
-            <a:srgbClr val="C97C2F"/>
-          </a:solidFill>
-          <a:ln>
-            <a:noFill/>
-          </a:ln>
-          <a:effectLst/>
-        </p:spPr>
-        <p:style>
-          <a:lnRef idx="1">
-            <a:schemeClr val="accent1"/>
-          </a:lnRef>
-          <a:fillRef idx="3">
-            <a:schemeClr val="accent1"/>
-          </a:fillRef>
-          <a:effectRef idx="2">
-            <a:schemeClr val="accent1"/>
-          </a:effectRef>
-          <a:fontRef idx="minor">
-            <a:schemeClr val="lt1"/>
-          </a:fontRef>
-        </p:style>
-        <p:txBody>
-          <a:bodyPr rtlCol="0" anchor="ctr"/>
-          <a:lstStyle/>
-          <a:p>
-            <a:pPr algn="ctr"/>
-          </a:p>
-        </p:txBody>
-      </p:sp>
-      <p:sp>
-        <p:nvSpPr>
-          <p:cNvPr id="4" name="TextBox 3"/>
-          <p:cNvSpPr txBox="1"/>
-          <p:nvPr/>
-        </p:nvSpPr>
-        <p:spPr>
-          <a:xfrm>
-            <a:off x="10378440" y="274320"/>
-            <a:ext cx="1600200" cy="502920"/>
-          </a:xfrm>
-          <a:prstGeom prst="rect">
-            <a:avLst/>
-          </a:prstGeom>
-          <a:noFill/>
-        </p:spPr>
-        <p:txBody>
-          <a:bodyPr wrap="square" anchor="ctr">
-            <a:spAutoFit/>
-          </a:bodyPr>
-          <a:lstStyle/>
-          <a:p>
-            <a:pPr algn="ctr"/>
-            <a:r>
-              <a:rPr sz="1300" b="1">
-                <a:solidFill>
-                  <a:srgbClr val="FFFFFF"/>
-                </a:solidFill>
-                <a:latin typeface="Calibri"/>
-              </a:rPr>
-              <a:t>3 min</a:t>
-            </a:r>
-          </a:p>
-        </p:txBody>
-      </p:sp>
-      <p:sp>
-        <p:nvSpPr>
-          <p:cNvPr id="5" name="TextBox 4"/>
+          <p:cNvPr id="3" name="TextBox 2"/>
           <p:cNvSpPr txBox="1"/>
           <p:nvPr/>
         </p:nvSpPr>
@@ -21973,7 +21183,7 @@
       </p:sp>
       <p:sp>
         <p:nvSpPr>
-          <p:cNvPr id="6" name="TextBox 5"/>
+          <p:cNvPr id="4" name="TextBox 3"/>
           <p:cNvSpPr txBox="1"/>
           <p:nvPr/>
         </p:nvSpPr>
@@ -22008,7 +21218,7 @@
       </p:sp>
       <p:pic>
         <p:nvPicPr>
-          <p:cNvPr id="7" name="Picture 6" descr="petstore_legacy_highlevel.png"/>
+          <p:cNvPr id="5" name="Picture 4" descr="petstore_legacy_highlevel.png"/>
           <p:cNvPicPr>
             <a:picLocks noChangeAspect="1"/>
           </p:cNvPicPr>

</xml_diff>

<commit_message>
Drop time budgets from agenda + title slide
Remove the 'Time' column from the agenda table and the '45-minute
session' timing line from the title slide, matching the earlier removal
of the per-slide minute chips. Agenda now shows # + Section only.
</commit_message>
<xml_diff>
--- a/docs/PetStore_Demo_45min.pptx
+++ b/docs/PetStore_Demo_45min.pptx
@@ -3326,7 +3326,7 @@
                 </a:solidFill>
                 <a:latin typeface="Calibri"/>
               </a:rPr>
-              <a:t>45-minute session · ~30 min narrative + ~10 min live code + ~5 min Q&amp;A</a:t>
+              <a:t>Narrative walkthrough · live code · Q&amp;A</a:t>
             </a:r>
           </a:p>
         </p:txBody>
@@ -10549,7 +10549,7 @@
                 </a:solidFill>
                 <a:latin typeface="Calibri"/>
               </a:rPr>
-              <a:t>How the 45 minutes are spent</a:t>
+              <a:t>What we'll walk through</a:t>
             </a:r>
           </a:p>
         </p:txBody>
@@ -10574,8 +10574,7 @@
               </a:tblPr>
               <a:tblGrid>
                 <a:gridCol w="731520"/>
-                <a:gridCol w="8686800"/>
-                <a:gridCol w="1828800"/>
+                <a:gridCol w="10515600"/>
               </a:tblGrid>
               <a:tr h="379827">
                 <a:tc>
@@ -10617,30 +10616,6 @@
                       </a:pPr>
                       <a:r>
                         <a:t>Section</a:t>
-                      </a:r>
-                    </a:p>
-                  </a:txBody>
-                  <a:tcPr anchor="ctr" marT="25400" marB="25400" marL="63500" marR="63500">
-                    <a:solidFill>
-                      <a:srgbClr val="1F3355"/>
-                    </a:solidFill>
-                  </a:tcPr>
-                </a:tc>
-                <a:tc>
-                  <a:txBody>
-                    <a:bodyPr/>
-                    <a:lstStyle/>
-                    <a:p>
-                      <a:pPr>
-                        <a:defRPr sz="1300" b="1">
-                          <a:solidFill>
-                            <a:srgbClr val="FFFFFF"/>
-                          </a:solidFill>
-                          <a:latin typeface="Calibri"/>
-                        </a:defRPr>
-                      </a:pPr>
-                      <a:r>
-                        <a:t>Time</a:t>
                       </a:r>
                     </a:p>
                   </a:txBody>
@@ -10700,30 +10675,6 @@
                     </a:solidFill>
                   </a:tcPr>
                 </a:tc>
-                <a:tc>
-                  <a:txBody>
-                    <a:bodyPr/>
-                    <a:lstStyle/>
-                    <a:p>
-                      <a:pPr>
-                        <a:defRPr sz="1300">
-                          <a:solidFill>
-                            <a:srgbClr val="1F3355"/>
-                          </a:solidFill>
-                          <a:latin typeface="Calibri"/>
-                        </a:defRPr>
-                      </a:pPr>
-                      <a:r>
-                        <a:t>2 min</a:t>
-                      </a:r>
-                    </a:p>
-                  </a:txBody>
-                  <a:tcPr anchor="ctr" marT="25400" marB="25400" marL="63500" marR="63500">
-                    <a:solidFill>
-                      <a:srgbClr val="FFFFFF"/>
-                    </a:solidFill>
-                  </a:tcPr>
-                </a:tc>
               </a:tr>
               <a:tr h="379827">
                 <a:tc>
@@ -10765,30 +10716,6 @@
                       </a:pPr>
                       <a:r>
                         <a:t>Legacy architecture — the starting point</a:t>
-                      </a:r>
-                    </a:p>
-                  </a:txBody>
-                  <a:tcPr anchor="ctr" marT="25400" marB="25400" marL="63500" marR="63500">
-                    <a:solidFill>
-                      <a:srgbClr val="F2F4F7"/>
-                    </a:solidFill>
-                  </a:tcPr>
-                </a:tc>
-                <a:tc>
-                  <a:txBody>
-                    <a:bodyPr/>
-                    <a:lstStyle/>
-                    <a:p>
-                      <a:pPr>
-                        <a:defRPr sz="1300">
-                          <a:solidFill>
-                            <a:srgbClr val="1F3355"/>
-                          </a:solidFill>
-                          <a:latin typeface="Calibri"/>
-                        </a:defRPr>
-                      </a:pPr>
-                      <a:r>
-                        <a:t>3 min</a:t>
                       </a:r>
                     </a:p>
                   </a:txBody>
@@ -10848,30 +10775,6 @@
                     </a:solidFill>
                   </a:tcPr>
                 </a:tc>
-                <a:tc>
-                  <a:txBody>
-                    <a:bodyPr/>
-                    <a:lstStyle/>
-                    <a:p>
-                      <a:pPr>
-                        <a:defRPr sz="1300">
-                          <a:solidFill>
-                            <a:srgbClr val="1F3355"/>
-                          </a:solidFill>
-                          <a:latin typeface="Calibri"/>
-                        </a:defRPr>
-                      </a:pPr>
-                      <a:r>
-                        <a:t>8 min</a:t>
-                      </a:r>
-                    </a:p>
-                  </a:txBody>
-                  <a:tcPr anchor="ctr" marT="25400" marB="25400" marL="63500" marR="63500">
-                    <a:solidFill>
-                      <a:srgbClr val="FFFFFF"/>
-                    </a:solidFill>
-                  </a:tcPr>
-                </a:tc>
               </a:tr>
               <a:tr h="379827">
                 <a:tc>
@@ -10913,30 +10816,6 @@
                       </a:pPr>
                       <a:r>
                         <a:t>Migration strategy &amp; principles</a:t>
-                      </a:r>
-                    </a:p>
-                  </a:txBody>
-                  <a:tcPr anchor="ctr" marT="25400" marB="25400" marL="63500" marR="63500">
-                    <a:solidFill>
-                      <a:srgbClr val="F2F4F7"/>
-                    </a:solidFill>
-                  </a:tcPr>
-                </a:tc>
-                <a:tc>
-                  <a:txBody>
-                    <a:bodyPr/>
-                    <a:lstStyle/>
-                    <a:p>
-                      <a:pPr>
-                        <a:defRPr sz="1300">
-                          <a:solidFill>
-                            <a:srgbClr val="1F3355"/>
-                          </a:solidFill>
-                          <a:latin typeface="Calibri"/>
-                        </a:defRPr>
-                      </a:pPr>
-                      <a:r>
-                        <a:t>3 min</a:t>
                       </a:r>
                     </a:p>
                   </a:txBody>
@@ -10996,30 +10875,6 @@
                     </a:solidFill>
                   </a:tcPr>
                 </a:tc>
-                <a:tc>
-                  <a:txBody>
-                    <a:bodyPr/>
-                    <a:lstStyle/>
-                    <a:p>
-                      <a:pPr>
-                        <a:defRPr sz="1300">
-                          <a:solidFill>
-                            <a:srgbClr val="1F3355"/>
-                          </a:solidFill>
-                          <a:latin typeface="Calibri"/>
-                        </a:defRPr>
-                      </a:pPr>
-                      <a:r>
-                        <a:t>5 min</a:t>
-                      </a:r>
-                    </a:p>
-                  </a:txBody>
-                  <a:tcPr anchor="ctr" marT="25400" marB="25400" marL="63500" marR="63500">
-                    <a:solidFill>
-                      <a:srgbClr val="FFFFFF"/>
-                    </a:solidFill>
-                  </a:tcPr>
-                </a:tc>
               </a:tr>
               <a:tr h="379827">
                 <a:tc>
@@ -11061,30 +10916,6 @@
                       </a:pPr>
                       <a:r>
                         <a:t>JMS message migration — XML → JSON (Anti-Corruption Layer)</a:t>
-                      </a:r>
-                    </a:p>
-                  </a:txBody>
-                  <a:tcPr anchor="ctr" marT="25400" marB="25400" marL="63500" marR="63500">
-                    <a:solidFill>
-                      <a:srgbClr val="F2F4F7"/>
-                    </a:solidFill>
-                  </a:tcPr>
-                </a:tc>
-                <a:tc>
-                  <a:txBody>
-                    <a:bodyPr/>
-                    <a:lstStyle/>
-                    <a:p>
-                      <a:pPr>
-                        <a:defRPr sz="1300">
-                          <a:solidFill>
-                            <a:srgbClr val="1F3355"/>
-                          </a:solidFill>
-                          <a:latin typeface="Calibri"/>
-                        </a:defRPr>
-                      </a:pPr>
-                      <a:r>
-                        <a:t>4 min</a:t>
                       </a:r>
                     </a:p>
                   </a:txBody>
@@ -11144,30 +10975,6 @@
                     </a:solidFill>
                   </a:tcPr>
                 </a:tc>
-                <a:tc>
-                  <a:txBody>
-                    <a:bodyPr/>
-                    <a:lstStyle/>
-                    <a:p>
-                      <a:pPr>
-                        <a:defRPr sz="1300">
-                          <a:solidFill>
-                            <a:srgbClr val="1F3355"/>
-                          </a:solidFill>
-                          <a:latin typeface="Calibri"/>
-                        </a:defRPr>
-                      </a:pPr>
-                      <a:r>
-                        <a:t>4 min</a:t>
-                      </a:r>
-                    </a:p>
-                  </a:txBody>
-                  <a:tcPr anchor="ctr" marT="25400" marB="25400" marL="63500" marR="63500">
-                    <a:solidFill>
-                      <a:srgbClr val="FFFFFF"/>
-                    </a:solidFill>
-                  </a:tcPr>
-                </a:tc>
               </a:tr>
               <a:tr h="379827">
                 <a:tc>
@@ -11209,30 +11016,6 @@
                       </a:pPr>
                       <a:r>
                         <a:t>Target as-built architecture</a:t>
-                      </a:r>
-                    </a:p>
-                  </a:txBody>
-                  <a:tcPr anchor="ctr" marT="25400" marB="25400" marL="63500" marR="63500">
-                    <a:solidFill>
-                      <a:srgbClr val="F2F4F7"/>
-                    </a:solidFill>
-                  </a:tcPr>
-                </a:tc>
-                <a:tc>
-                  <a:txBody>
-                    <a:bodyPr/>
-                    <a:lstStyle/>
-                    <a:p>
-                      <a:pPr>
-                        <a:defRPr sz="1300">
-                          <a:solidFill>
-                            <a:srgbClr val="1F3355"/>
-                          </a:solidFill>
-                          <a:latin typeface="Calibri"/>
-                        </a:defRPr>
-                      </a:pPr>
-                      <a:r>
-                        <a:t>3 min</a:t>
                       </a:r>
                     </a:p>
                   </a:txBody>
@@ -11292,30 +11075,6 @@
                     </a:solidFill>
                   </a:tcPr>
                 </a:tc>
-                <a:tc>
-                  <a:txBody>
-                    <a:bodyPr/>
-                    <a:lstStyle/>
-                    <a:p>
-                      <a:pPr>
-                        <a:defRPr sz="1300">
-                          <a:solidFill>
-                            <a:srgbClr val="1F3355"/>
-                          </a:solidFill>
-                          <a:latin typeface="Calibri"/>
-                        </a:defRPr>
-                      </a:pPr>
-                      <a:r>
-                        <a:t>8 min</a:t>
-                      </a:r>
-                    </a:p>
-                  </a:txBody>
-                  <a:tcPr anchor="ctr" marT="25400" marB="25400" marL="63500" marR="63500">
-                    <a:solidFill>
-                      <a:srgbClr val="FFFFFF"/>
-                    </a:solidFill>
-                  </a:tcPr>
-                </a:tc>
               </a:tr>
               <a:tr h="379827">
                 <a:tc>
@@ -11357,30 +11116,6 @@
                       </a:pPr>
                       <a:r>
                         <a:t>CODE WALKTHROUGH (live)</a:t>
-                      </a:r>
-                    </a:p>
-                  </a:txBody>
-                  <a:tcPr anchor="ctr" marT="25400" marB="25400" marL="63500" marR="63500">
-                    <a:solidFill>
-                      <a:srgbClr val="F2F4F7"/>
-                    </a:solidFill>
-                  </a:tcPr>
-                </a:tc>
-                <a:tc>
-                  <a:txBody>
-                    <a:bodyPr/>
-                    <a:lstStyle/>
-                    <a:p>
-                      <a:pPr>
-                        <a:defRPr sz="1300">
-                          <a:solidFill>
-                            <a:srgbClr val="1F3355"/>
-                          </a:solidFill>
-                          <a:latin typeface="Calibri"/>
-                        </a:defRPr>
-                      </a:pPr>
-                      <a:r>
-                        <a:t>10 min</a:t>
                       </a:r>
                     </a:p>
                   </a:txBody>
@@ -11440,30 +11175,6 @@
                     </a:solidFill>
                   </a:tcPr>
                 </a:tc>
-                <a:tc>
-                  <a:txBody>
-                    <a:bodyPr/>
-                    <a:lstStyle/>
-                    <a:p>
-                      <a:pPr>
-                        <a:defRPr sz="1300">
-                          <a:solidFill>
-                            <a:srgbClr val="1F3355"/>
-                          </a:solidFill>
-                          <a:latin typeface="Calibri"/>
-                        </a:defRPr>
-                      </a:pPr>
-                      <a:r>
-                        <a:t>2 min</a:t>
-                      </a:r>
-                    </a:p>
-                  </a:txBody>
-                  <a:tcPr anchor="ctr" marT="25400" marB="25400" marL="63500" marR="63500">
-                    <a:solidFill>
-                      <a:srgbClr val="FFFFFF"/>
-                    </a:solidFill>
-                  </a:tcPr>
-                </a:tc>
               </a:tr>
               <a:tr h="379836">
                 <a:tc>
@@ -11505,30 +11216,6 @@
                       </a:pPr>
                       <a:r>
                         <a:t>Wrap-up &amp; Q&amp;A</a:t>
-                      </a:r>
-                    </a:p>
-                  </a:txBody>
-                  <a:tcPr anchor="ctr" marT="25400" marB="25400" marL="63500" marR="63500">
-                    <a:solidFill>
-                      <a:srgbClr val="F2F4F7"/>
-                    </a:solidFill>
-                  </a:tcPr>
-                </a:tc>
-                <a:tc>
-                  <a:txBody>
-                    <a:bodyPr/>
-                    <a:lstStyle/>
-                    <a:p>
-                      <a:pPr>
-                        <a:defRPr sz="1300">
-                          <a:solidFill>
-                            <a:srgbClr val="1F3355"/>
-                          </a:solidFill>
-                          <a:latin typeface="Calibri"/>
-                        </a:defRPr>
-                      </a:pPr>
-                      <a:r>
-                        <a:t>5 min</a:t>
                       </a:r>
                     </a:p>
                   </a:txBody>

</xml_diff>

<commit_message>
Deck E5: add chokepoint lifecycle guard + MongoDB @Version-still-needed note
E5 now covers both order-status protections: the @Version optimistic lock (concurrency)
AND the store-chokepoint PENDING->APPROVED->COMPLETED lifecycle guard (direction), plus the
clarification that MongoDB single-document atomicity does not remove the need for @Version
(updateStatus is a two-round-trip read-modify-write). Regenerated, zero overflow.
</commit_message>
<xml_diff>
--- a/docs/PetStore_Demo_45min.pptx
+++ b/docs/PetStore_Demo_45min.pptx
@@ -13593,7 +13593,7 @@
                 </a:solidFill>
                 <a:latin typeface="Calibri"/>
               </a:rPr>
-              <a:t>Enhancement 5 — Optimistic locking on order status</a:t>
+              <a:t>Enhancement 5 — Optimistic lock + lifecycle guard on order status</a:t>
             </a:r>
           </a:p>
         </p:txBody>
@@ -13628,7 +13628,7 @@
                 </a:solidFill>
                 <a:latin typeface="Calibri"/>
               </a:rPr>
-              <a:t>Concurrent approve + deny can no longer both win</a:t>
+              <a:t>Concurrent approve+deny can't both win — and a done order can't be reversed</a:t>
             </a:r>
           </a:p>
         </p:txBody>
@@ -13718,7 +13718,23 @@
                 </a:solidFill>
                 <a:latin typeface="Calibri"/>
               </a:rPr>
-              <a:t>•  A lost update could leave the order in an inconsistent state, or fire both an approval AND a denial event.</a:t>
+              <a:t>•  A lost update could leave the order inconsistent, or fire both an approval AND a denial event.</a:t>
+            </a:r>
+          </a:p>
+          <a:p>
+            <a:pPr>
+              <a:spcAft>
+                <a:spcPts val="500"/>
+              </a:spcAft>
+            </a:pPr>
+            <a:r>
+              <a:rPr sz="1300" b="0">
+                <a:solidFill>
+                  <a:srgbClr val="B23A48"/>
+                </a:solidFill>
+                <a:latin typeface="Calibri"/>
+              </a:rPr>
+              <a:t>•  Direction was unguarded at the store: a stray writer could reverse a terminal order (COMPLETED → APPROVED).</a:t>
             </a:r>
           </a:p>
         </p:txBody>
@@ -13792,7 +13808,7 @@
                 </a:solidFill>
                 <a:latin typeface="Calibri"/>
               </a:rPr>
-              <a:t>•  A clean, race-free order lifecycle without holding a DB lock across the whole request.</a:t>
+              <a:t>•  A clean, race-free, one-directional order lifecycle without holding a DB lock across the request.</a:t>
             </a:r>
           </a:p>
           <a:p>
@@ -13808,7 +13824,7 @@
                 </a:solidFill>
                 <a:latin typeface="Calibri"/>
               </a:rPr>
-              <a:t>•  Cheap: one integer column + a mapped exception.</a:t>
+              <a:t>•  Cheap: one integer column, a mapped exception, and a guard no future caller can bypass.</a:t>
             </a:r>
           </a:p>
         </p:txBody>
@@ -13926,7 +13942,7 @@
                 </a:solidFill>
                 <a:latin typeface="Calibri"/>
               </a:rPr>
-              <a:t>•  A @Version column on the order: the first writer commits, the second hits a stale version.</a:t>
+              <a:t>•  Concurrency: a @Version column — first writer commits, the second hits a stale version → OptimisticLockingFailureException → HTTP 409.</a:t>
             </a:r>
           </a:p>
           <a:p>
@@ -13936,13 +13952,29 @@
               </a:spcAft>
             </a:pPr>
             <a:r>
+              <a:rPr sz="1300" b="1">
+                <a:solidFill>
+                  <a:srgbClr val="1F3355"/>
+                </a:solidFill>
+                <a:latin typeface="Calibri"/>
+              </a:rPr>
+              <a:t>•  Direction: the PENDING→APPROVED→COMPLETED (and →DENIED) lifecycle is enforced INSIDE the store's updateStatus — the chokepoint every writer passes through, not just the call sites.</a:t>
+            </a:r>
+          </a:p>
+          <a:p>
+            <a:pPr>
+              <a:spcAft>
+                <a:spcPts val="600"/>
+              </a:spcAft>
+            </a:pPr>
+            <a:r>
               <a:rPr sz="1300" b="0">
                 <a:solidFill>
                   <a:srgbClr val="1F3355"/>
                 </a:solidFill>
                 <a:latin typeface="Calibri"/>
               </a:rPr>
-              <a:t>•  The stale write throws OptimisticLockingFailureException → mapped to HTTP 409 Conflict.</a:t>
+              <a:t>•  An illegal move (e.g. COMPLETED→APPROVED, or skipping APPROVED) → 409; a same-status write is an idempotent no-op (JMS-redelivery safe).</a:t>
             </a:r>
           </a:p>
           <a:p>
@@ -13954,11 +13986,11 @@
             <a:r>
               <a:rPr sz="1300" b="0">
                 <a:solidFill>
-                  <a:srgbClr val="1F3355"/>
-                </a:solidFill>
-                <a:latin typeface="Calibri"/>
-              </a:rPr>
-              <a:t>•  Preserved on MongoDB too (Spring Data version-guarded conditional update).</a:t>
+                  <a:srgbClr val="2F8F46"/>
+                </a:solidFill>
+                <a:latin typeface="Calibri"/>
+              </a:rPr>
+              <a:t>•  On MongoDB, @Version is STILL required: updateStatus is a read-modify-write across two round trips, so single-document atomicity alone does not stop the lost update.</a:t>
             </a:r>
           </a:p>
         </p:txBody>
@@ -13993,7 +14025,7 @@
                 </a:solidFill>
                 <a:latin typeface="Consolas"/>
               </a:rPr>
-              <a:t>order-processing-service/.../repository/jpa/WarehouseOrderEntity.java (@Version)</a:t>
+              <a:t>opc/.../repository/OrderStore.java (updateStatus guard) · jpa+mongo OrderStore · WarehouseOrderEntity (@Version)</a:t>
             </a:r>
           </a:p>
         </p:txBody>

</xml_diff>